<commit_message>
Rename project to College Complaints Portal across all app, PPT, PDF, and docs
</commit_message>
<xml_diff>
--- a/College_Complaints_Portal_Presentation.pptx
+++ b/College_Complaints_Portal_Presentation.pptx
@@ -865,7 +865,7 @@
           <a:p>
             <a:r>
               <a:rPr lang="en-US" dirty="0"/>
-              <a:t>Explain the legal and institutional motivation behind CampusSamadhan: mandatory compliance with UGC/AICTE regulations, speeding up maintenance resolution, and safeguarding student privacy.</a:t>
+              <a:t>Explain the legal and institutional motivation behind College Complaints Portal: mandatory compliance with UGC/AICTE regulations, speeding up maintenance resolution, and safeguarding student privacy.</a:t>
             </a:r>
             <a:endParaRPr lang="en-US" dirty="0"/>
           </a:p>
@@ -1883,23 +1883,23 @@
         <p:spPr>
           <a:xfrm>
             <a:off x="1005840" y="457200"/>
-            <a:ext cx="9601200" cy="731520"/>
-          </a:xfrm>
-          <a:prstGeom prst="rect">
-            <a:avLst/>
-          </a:prstGeom>
-          <a:noFill/>
-          <a:ln/>
-        </p:spPr>
-        <p:txBody>
-          <a:bodyPr wrap="square" rtlCol="0" anchor="ctr"/>
-          <a:lstStyle/>
-          <a:p>
-            <a:pPr indent="0" marL="0">
-              <a:buNone/>
-            </a:pPr>
-            <a:r>
-              <a:rPr lang="en-US" sz="4000" b="1" dirty="0">
+            <a:ext cx="10058400" cy="731520"/>
+          </a:xfrm>
+          <a:prstGeom prst="rect">
+            <a:avLst/>
+          </a:prstGeom>
+          <a:noFill/>
+          <a:ln/>
+        </p:spPr>
+        <p:txBody>
+          <a:bodyPr wrap="square" rtlCol="0" anchor="ctr"/>
+          <a:lstStyle/>
+          <a:p>
+            <a:pPr indent="0" marL="0">
+              <a:buNone/>
+            </a:pPr>
+            <a:r>
+              <a:rPr lang="en-US" sz="3800" b="1" dirty="0">
                 <a:solidFill>
                   <a:srgbClr val="FFFFFF"/>
                 </a:solidFill>
@@ -1907,9 +1907,9 @@
                 <a:ea typeface="Arial" pitchFamily="34" charset="-122"/>
                 <a:cs typeface="Arial" pitchFamily="34" charset="-120"/>
               </a:rPr>
-              <a:t>CampusSamadhan</a:t>
-            </a:r>
-            <a:endParaRPr lang="en-US" sz="4000" dirty="0"/>
+              <a:t>College Complaints Portal</a:t>
+            </a:r>
+            <a:endParaRPr lang="en-US" sz="3800" dirty="0"/>
           </a:p>
         </p:txBody>
       </p:sp>
@@ -2572,7 +2572,7 @@
                 <a:ea typeface="Arial" pitchFamily="34" charset="-122"/>
                 <a:cs typeface="Arial" pitchFamily="34" charset="-120"/>
               </a:rPr>
-              <a:t>CAMPUSSAMADHAN | COLLEGE COMPLAINTS PORTAL</a:t>
+              <a:t>COLLEGE COMPLAINTS PORTAL | GRIEVANCE SYSTEM</a:t>
             </a:r>
             <a:endParaRPr lang="en-US" sz="900" dirty="0"/>
           </a:p>
@@ -3593,7 +3593,7 @@
                 <a:ea typeface="Arial" pitchFamily="34" charset="-122"/>
                 <a:cs typeface="Arial" pitchFamily="34" charset="-120"/>
               </a:rPr>
-              <a:t>CAMPUSSAMADHAN | COLLEGE COMPLAINTS PORTAL</a:t>
+              <a:t>COLLEGE COMPLAINTS PORTAL | GRIEVANCE SYSTEM</a:t>
             </a:r>
             <a:endParaRPr lang="en-US" sz="900" dirty="0"/>
           </a:p>
@@ -4225,7 +4225,7 @@
                 <a:ea typeface="Arial" pitchFamily="34" charset="-122"/>
                 <a:cs typeface="Arial" pitchFamily="34" charset="-120"/>
               </a:rPr>
-              <a:t>CAMPUSSAMADHAN | COLLEGE COMPLAINTS PORTAL</a:t>
+              <a:t>COLLEGE COMPLAINTS PORTAL | GRIEVANCE SYSTEM</a:t>
             </a:r>
             <a:endParaRPr lang="en-US" sz="900" dirty="0"/>
           </a:p>
@@ -4722,7 +4722,7 @@
                 <a:ea typeface="Arial" pitchFamily="34" charset="-122"/>
                 <a:cs typeface="Arial" pitchFamily="34" charset="-120"/>
               </a:rPr>
-              <a:t>CAMPUSSAMADHAN | COLLEGE COMPLAINTS PORTAL</a:t>
+              <a:t>COLLEGE COMPLAINTS PORTAL | GRIEVANCE SYSTEM</a:t>
             </a:r>
             <a:endParaRPr lang="en-US" sz="900" dirty="0"/>
           </a:p>
@@ -5347,7 +5347,7 @@
                 <a:ea typeface="Arial" pitchFamily="34" charset="-122"/>
                 <a:cs typeface="Arial" pitchFamily="34" charset="-120"/>
               </a:rPr>
-              <a:t>CAMPUSSAMADHAN | COLLEGE COMPLAINTS PORTAL</a:t>
+              <a:t>COLLEGE COMPLAINTS PORTAL | GRIEVANCE SYSTEM</a:t>
             </a:r>
             <a:endParaRPr lang="en-US" sz="900" dirty="0"/>
           </a:p>
@@ -6135,7 +6135,7 @@
                 <a:ea typeface="Arial" pitchFamily="34" charset="-122"/>
                 <a:cs typeface="Arial" pitchFamily="34" charset="-120"/>
               </a:rPr>
-              <a:t>CAMPUSSAMADHAN | COLLEGE COMPLAINTS PORTAL</a:t>
+              <a:t>COLLEGE COMPLAINTS PORTAL | GRIEVANCE SYSTEM</a:t>
             </a:r>
             <a:endParaRPr lang="en-US" sz="900" dirty="0"/>
           </a:p>
@@ -7297,7 +7297,7 @@
                 <a:ea typeface="Arial" pitchFamily="34" charset="-122"/>
                 <a:cs typeface="Arial" pitchFamily="34" charset="-120"/>
               </a:rPr>
-              <a:t>CAMPUSSAMADHAN | COLLEGE COMPLAINTS PORTAL</a:t>
+              <a:t>COLLEGE COMPLAINTS PORTAL | GRIEVANCE SYSTEM</a:t>
             </a:r>
             <a:endParaRPr lang="en-US" sz="900" dirty="0"/>
           </a:p>
@@ -7929,7 +7929,7 @@
                 <a:ea typeface="Arial" pitchFamily="34" charset="-122"/>
                 <a:cs typeface="Arial" pitchFamily="34" charset="-120"/>
               </a:rPr>
-              <a:t>CAMPUSSAMADHAN | COLLEGE COMPLAINTS PORTAL</a:t>
+              <a:t>COLLEGE COMPLAINTS PORTAL | GRIEVANCE SYSTEM</a:t>
             </a:r>
             <a:endParaRPr lang="en-US" sz="900" dirty="0"/>
           </a:p>
@@ -8610,7 +8610,7 @@
                 <a:ea typeface="Arial" pitchFamily="34" charset="-122"/>
                 <a:cs typeface="Arial" pitchFamily="34" charset="-120"/>
               </a:rPr>
-              <a:t>CAMPUSSAMADHAN | COLLEGE COMPLAINTS PORTAL</a:t>
+              <a:t>COLLEGE COMPLAINTS PORTAL | GRIEVANCE SYSTEM</a:t>
             </a:r>
             <a:endParaRPr lang="en-US" sz="900" dirty="0"/>
           </a:p>
@@ -9626,7 +9626,7 @@
                 <a:ea typeface="Arial" pitchFamily="34" charset="-122"/>
                 <a:cs typeface="Arial" pitchFamily="34" charset="-120"/>
               </a:rPr>
-              <a:t>CAMPUSSAMADHAN | COLLEGE COMPLAINTS PORTAL</a:t>
+              <a:t>COLLEGE COMPLAINTS PORTAL | GRIEVANCE SYSTEM</a:t>
             </a:r>
             <a:endParaRPr lang="en-US" sz="900" dirty="0"/>
           </a:p>
@@ -10548,7 +10548,7 @@
                 <a:ea typeface="Arial" pitchFamily="34" charset="-122"/>
                 <a:cs typeface="Arial" pitchFamily="34" charset="-120"/>
               </a:rPr>
-              <a:t>CAMPUSSAMADHAN | COLLEGE COMPLAINTS PORTAL</a:t>
+              <a:t>COLLEGE COMPLAINTS PORTAL | GRIEVANCE SYSTEM</a:t>
             </a:r>
             <a:endParaRPr lang="en-US" sz="900" dirty="0"/>
           </a:p>
@@ -10791,7 +10791,7 @@
                 <a:ea typeface="Arial" pitchFamily="34" charset="-122"/>
                 <a:cs typeface="Arial" pitchFamily="34" charset="-120"/>
               </a:rPr>
-              <a:t>In compliance with statutory Supreme Court of India &amp; UGC mandates, CampusSamadhan features a dedicated high-priority Emergency SOS system. Students facing immediate danger, ragging, or harassment can trigger an instant alert with zero latency.</a:t>
+              <a:t>In compliance with statutory Supreme Court of India &amp; UGC mandates, College Complaints Portal features a dedicated high-priority Emergency SOS system. Students facing immediate danger, ragging, or harassment can trigger an instant alert with zero latency.</a:t>
             </a:r>
             <a:endParaRPr lang="en-US" sz="1000" dirty="0"/>
           </a:p>

</xml_diff>